<commit_message>
Simplify measurement system: MPU-6050, 100 Hz video truth, no encoder
Co-Authored-By: Claude Sonnet 5.5 <noreply@anthropic.com>
Claude-Session: https://claude.ai/code/session_01MiS8WfuBcRuGUBx67AAY5i
</commit_message>
<xml_diff>
--- a/slides/midterm_presentation.pptx
+++ b/slides/midterm_presentation.pptx
@@ -601,7 +601,7 @@
           <a:p>
             <a:r>
               <a:rPr lang="en-US" dirty="0"/>
-              <a:t>실험은 참값 확보를 기준으로 설계했습니다. 벤치 실험은 서보로 구동하는 정강이 모형에서 엔코더 각도를 참값으로 쓰며, 충돌과 진동모터로 잡음 조건을 통제합니다. 인체 보행 실험은 3명에서 5명이 트레드밀을 세 속도로 걷고, 240 프레임 영상에서 판독한 heel strike와 toe-off를 참값으로, 동기 LED로 시간을 맞춰 이벤트 검출 시점 오차를 비교합니다. 임베디드 실험은 동일한 raw 데이터를 MCU에 재생해 연산 비용과 PC 출력과의 수치적 일치를 확인합니다.</a:t>
+              <a:t>실험은 참값 확보를 기준으로 설계했습니다. 벤치 실험은 서보 모터로 구동하는 정강이 모형을 영상으로 촬영해 참값으로 쓰며, 충돌과 진동모터로 잡음 조건을 통제합니다. 인체 보행 실험은 3명에서 5명이 트레드밀을 세 속도로 걷고, 100 헤르츠 영상에서 판독한 heel strike와 toe-off를 참값으로, 동기 LED로 시간을 맞춰 이벤트 검출 시점 오차를 비교합니다. 임베디드 실험은 동일한 raw 데이터를 MCU에 재생해 연산 비용과 PC 출력과의 수치적 일치를 확인합니다.</a:t>
             </a:r>
             <a:endParaRPr lang="en-US" dirty="0"/>
           </a:p>
@@ -1393,7 +1393,7 @@
           <a:p>
             <a:r>
               <a:rPr lang="en-US" dirty="0"/>
-              <a:t>측정 시스템입니다. 정강이 IMU, 보행 이벤트 참값을 위한 240 fps 카메라와 동기 LED, 벤치 각도 참값을 위한 자기 엔코더를 STM32에 연결하며, LED를 STM32가 점등해 영상과 시간을 맞추고, 1 마이크로초 타이머로 공통 타임스탬프를 부여합니다. 지연을 밀리초 단위로 측정하려면 단일 클럭 동기화가 전제 조건이기 때문입니다. STM32는 인과 필터와 고정지연 필터를 실시간으로 계산해 raw와 함께 PC로 전송하고, PC에서는 비인과 필터와 분석을 수행합니다. 아두이노는 벤치의 서보 구동과, 저사양 MCU에서의 연산 비용 비교에 사용합니다.</a:t>
+              <a:t>측정 시스템입니다. 정강이에 부착한 MPU-6050 IMU와, 보행 이벤트 참값을 위한 100 헤르츠 카메라와 동기 LED를 STM32에 연결합니다. LED를 STM32가 점등해 영상과 시간을 맞추고, 모든 센서에 같은 클럭으로 타임스탬프를 부여합니다. 지연을 밀리초 단위로 측정하려면 단일 클럭 동기화가 전제 조건이기 때문입니다. STM32는 인과 필터와 고정지연 필터를 실시간으로 계산해 raw와 함께 PC로 전송하고, PC에서는 비인과 필터와 분석을 수행합니다. 아두이노는 벤치의 서보 모터 구동과, 저사양 MCU에서의 연산 비용 비교에 사용합니다.</a:t>
             </a:r>
             <a:endParaRPr lang="en-US" dirty="0"/>
           </a:p>
@@ -2392,7 +2392,7 @@
                 <a:ea typeface="Malgun Gothic" pitchFamily="34" charset="-122"/>
                 <a:cs typeface="Malgun Gothic" pitchFamily="34" charset="-120"/>
               </a:rPr>
-              <a:t>참값: AS5600 엔코더 각도</a:t>
+              <a:t>참값: 영상 (100 Hz)</a:t>
             </a:r>
             <a:endParaRPr lang="en-US" sz="1400" dirty="0"/>
           </a:p>
@@ -2435,7 +2435,7 @@
                 <a:ea typeface="Malgun Gothic" pitchFamily="34" charset="-122"/>
                 <a:cs typeface="Malgun Gothic" pitchFamily="34" charset="-120"/>
               </a:rPr>
-              <a:t>서보 구동 링크 (정강이 모형)</a:t>
+              <a:t>서보 모터 구동 링크 (정강이 모형)</a:t>
             </a:r>
             <a:endParaRPr lang="en-US" sz="1600" dirty="0"/>
           </a:p>
@@ -2621,7 +2621,7 @@
                 <a:ea typeface="Malgun Gothic" pitchFamily="34" charset="-122"/>
                 <a:cs typeface="Malgun Gothic" pitchFamily="34" charset="-120"/>
               </a:rPr>
-              <a:t>참값: 고속 영상 (240 fps)</a:t>
+              <a:t>참값: 영상 (100 Hz)</a:t>
             </a:r>
             <a:endParaRPr lang="en-US" sz="1400" dirty="0"/>
           </a:p>
@@ -10521,12 +10521,12 @@
         </p:nvSpPr>
         <p:spPr>
           <a:xfrm>
-            <a:off x="640080" y="1691640"/>
-            <a:ext cx="3291840" cy="914400"/>
+            <a:off x="640080" y="1783080"/>
+            <a:ext cx="3383280" cy="1051560"/>
           </a:xfrm>
           <a:prstGeom prst="roundRect">
             <a:avLst>
-              <a:gd name="adj" fmla="val 10000"/>
+              <a:gd name="adj" fmla="val 8696"/>
             </a:avLst>
           </a:prstGeom>
           <a:solidFill>
@@ -10548,24 +10548,24 @@
         </p:nvSpPr>
         <p:spPr>
           <a:xfrm>
-            <a:off x="822960" y="1801368"/>
-            <a:ext cx="2926080" cy="365760"/>
-          </a:xfrm>
-          <a:prstGeom prst="rect">
-            <a:avLst/>
-          </a:prstGeom>
-          <a:noFill/>
-          <a:ln/>
-        </p:spPr>
-        <p:txBody>
-          <a:bodyPr wrap="square" lIns="0" tIns="0" rIns="0" bIns="0" rtlCol="0" anchor="t"/>
-          <a:lstStyle/>
-          <a:p>
-            <a:pPr indent="0" marL="0">
-              <a:buNone/>
-            </a:pPr>
-            <a:r>
-              <a:rPr lang="en-US" sz="1600" b="1" dirty="0">
+            <a:off x="868680" y="1920240"/>
+            <a:ext cx="2926080" cy="411480"/>
+          </a:xfrm>
+          <a:prstGeom prst="rect">
+            <a:avLst/>
+          </a:prstGeom>
+          <a:noFill/>
+          <a:ln/>
+        </p:spPr>
+        <p:txBody>
+          <a:bodyPr wrap="square" lIns="0" tIns="0" rIns="0" bIns="0" rtlCol="0" anchor="t"/>
+          <a:lstStyle/>
+          <a:p>
+            <a:pPr indent="0" marL="0">
+              <a:buNone/>
+            </a:pPr>
+            <a:r>
+              <a:rPr lang="en-US" sz="1800" b="1" dirty="0">
                 <a:solidFill>
                   <a:srgbClr val="16202E"/>
                 </a:solidFill>
@@ -10573,9 +10573,9 @@
                 <a:ea typeface="Malgun Gothic" pitchFamily="34" charset="-122"/>
                 <a:cs typeface="Malgun Gothic" pitchFamily="34" charset="-120"/>
               </a:rPr>
-              <a:t>IMU · ICM-42688-P</a:t>
-            </a:r>
-            <a:endParaRPr lang="en-US" sz="1600" dirty="0"/>
+              <a:t>IMU · MPU-6050</a:t>
+            </a:r>
+            <a:endParaRPr lang="en-US" sz="1800" dirty="0"/>
           </a:p>
         </p:txBody>
       </p:sp>
@@ -10587,24 +10587,24 @@
         </p:nvSpPr>
         <p:spPr>
           <a:xfrm>
-            <a:off x="822960" y="2194560"/>
-            <a:ext cx="2926080" cy="365760"/>
-          </a:xfrm>
-          <a:prstGeom prst="rect">
-            <a:avLst/>
-          </a:prstGeom>
-          <a:noFill/>
-          <a:ln/>
-        </p:spPr>
-        <p:txBody>
-          <a:bodyPr wrap="square" lIns="0" tIns="0" rIns="0" bIns="0" rtlCol="0" anchor="t"/>
-          <a:lstStyle/>
-          <a:p>
-            <a:pPr indent="0" marL="0">
-              <a:buNone/>
-            </a:pPr>
-            <a:r>
-              <a:rPr lang="en-US" sz="1300" dirty="0">
+            <a:off x="868680" y="2377440"/>
+            <a:ext cx="2926080" cy="411480"/>
+          </a:xfrm>
+          <a:prstGeom prst="rect">
+            <a:avLst/>
+          </a:prstGeom>
+          <a:noFill/>
+          <a:ln/>
+        </p:spPr>
+        <p:txBody>
+          <a:bodyPr wrap="square" lIns="0" tIns="0" rIns="0" bIns="0" rtlCol="0" anchor="t"/>
+          <a:lstStyle/>
+          <a:p>
+            <a:pPr indent="0" marL="0">
+              <a:buNone/>
+            </a:pPr>
+            <a:r>
+              <a:rPr lang="en-US" sz="1400" dirty="0">
                 <a:solidFill>
                   <a:srgbClr val="646D7A"/>
                 </a:solidFill>
@@ -10612,9 +10612,9 @@
                 <a:ea typeface="Malgun Gothic" pitchFamily="34" charset="-122"/>
                 <a:cs typeface="Malgun Gothic" pitchFamily="34" charset="-120"/>
               </a:rPr>
-              <a:t>정강이 각속도 · SPI 1 kHz</a:t>
-            </a:r>
-            <a:endParaRPr lang="en-US" sz="1300" dirty="0"/>
+              <a:t>정강이 각속도 · I2C</a:t>
+            </a:r>
+            <a:endParaRPr lang="en-US" sz="1400" dirty="0"/>
           </a:p>
         </p:txBody>
       </p:sp>
@@ -10626,12 +10626,12 @@
         </p:nvSpPr>
         <p:spPr>
           <a:xfrm>
-            <a:off x="640080" y="2743200"/>
-            <a:ext cx="3291840" cy="914400"/>
+            <a:off x="640080" y="3017520"/>
+            <a:ext cx="3383280" cy="1051560"/>
           </a:xfrm>
           <a:prstGeom prst="roundRect">
             <a:avLst>
-              <a:gd name="adj" fmla="val 10000"/>
+              <a:gd name="adj" fmla="val 8696"/>
             </a:avLst>
           </a:prstGeom>
           <a:solidFill>
@@ -10653,24 +10653,24 @@
         </p:nvSpPr>
         <p:spPr>
           <a:xfrm>
-            <a:off x="822960" y="2852928"/>
-            <a:ext cx="2926080" cy="365760"/>
-          </a:xfrm>
-          <a:prstGeom prst="rect">
-            <a:avLst/>
-          </a:prstGeom>
-          <a:noFill/>
-          <a:ln/>
-        </p:spPr>
-        <p:txBody>
-          <a:bodyPr wrap="square" lIns="0" tIns="0" rIns="0" bIns="0" rtlCol="0" anchor="t"/>
-          <a:lstStyle/>
-          <a:p>
-            <a:pPr indent="0" marL="0">
-              <a:buNone/>
-            </a:pPr>
-            <a:r>
-              <a:rPr lang="en-US" sz="1600" b="1" dirty="0">
+            <a:off x="868680" y="3154680"/>
+            <a:ext cx="2926080" cy="411480"/>
+          </a:xfrm>
+          <a:prstGeom prst="rect">
+            <a:avLst/>
+          </a:prstGeom>
+          <a:noFill/>
+          <a:ln/>
+        </p:spPr>
+        <p:txBody>
+          <a:bodyPr wrap="square" lIns="0" tIns="0" rIns="0" bIns="0" rtlCol="0" anchor="t"/>
+          <a:lstStyle/>
+          <a:p>
+            <a:pPr indent="0" marL="0">
+              <a:buNone/>
+            </a:pPr>
+            <a:r>
+              <a:rPr lang="en-US" sz="1800" b="1" dirty="0">
                 <a:solidFill>
                   <a:srgbClr val="16202E"/>
                 </a:solidFill>
@@ -10678,9 +10678,9 @@
                 <a:ea typeface="Malgun Gothic" pitchFamily="34" charset="-122"/>
                 <a:cs typeface="Malgun Gothic" pitchFamily="34" charset="-120"/>
               </a:rPr>
-              <a:t>고속 카메라 + 동기 LED</a:t>
-            </a:r>
-            <a:endParaRPr lang="en-US" sz="1600" dirty="0"/>
+              <a:t>카메라 + 동기 LED</a:t>
+            </a:r>
+            <a:endParaRPr lang="en-US" sz="1800" dirty="0"/>
           </a:p>
         </p:txBody>
       </p:sp>
@@ -10692,24 +10692,24 @@
         </p:nvSpPr>
         <p:spPr>
           <a:xfrm>
-            <a:off x="822960" y="3246120"/>
-            <a:ext cx="2926080" cy="365760"/>
-          </a:xfrm>
-          <a:prstGeom prst="rect">
-            <a:avLst/>
-          </a:prstGeom>
-          <a:noFill/>
-          <a:ln/>
-        </p:spPr>
-        <p:txBody>
-          <a:bodyPr wrap="square" lIns="0" tIns="0" rIns="0" bIns="0" rtlCol="0" anchor="t"/>
-          <a:lstStyle/>
-          <a:p>
-            <a:pPr indent="0" marL="0">
-              <a:buNone/>
-            </a:pPr>
-            <a:r>
-              <a:rPr lang="en-US" sz="1300" dirty="0">
+            <a:off x="868680" y="3611880"/>
+            <a:ext cx="2926080" cy="411480"/>
+          </a:xfrm>
+          <a:prstGeom prst="rect">
+            <a:avLst/>
+          </a:prstGeom>
+          <a:noFill/>
+          <a:ln/>
+        </p:spPr>
+        <p:txBody>
+          <a:bodyPr wrap="square" lIns="0" tIns="0" rIns="0" bIns="0" rtlCol="0" anchor="t"/>
+          <a:lstStyle/>
+          <a:p>
+            <a:pPr indent="0" marL="0">
+              <a:buNone/>
+            </a:pPr>
+            <a:r>
+              <a:rPr lang="en-US" sz="1400" dirty="0">
                 <a:solidFill>
                   <a:srgbClr val="646D7A"/>
                 </a:solidFill>
@@ -10717,9 +10717,9 @@
                 <a:ea typeface="Malgun Gothic" pitchFamily="34" charset="-122"/>
                 <a:cs typeface="Malgun Gothic" pitchFamily="34" charset="-120"/>
               </a:rPr>
-              <a:t>240 fps · 보행 이벤트 참값</a:t>
-            </a:r>
-            <a:endParaRPr lang="en-US" sz="1300" dirty="0"/>
+              <a:t>100 Hz 촬영 · 보행 이벤트 참값</a:t>
+            </a:r>
+            <a:endParaRPr lang="en-US" sz="1400" dirty="0"/>
           </a:p>
         </p:txBody>
       </p:sp>
@@ -10731,12 +10731,274 @@
         </p:nvSpPr>
         <p:spPr>
           <a:xfrm>
-            <a:off x="640080" y="3794760"/>
-            <a:ext cx="3291840" cy="914400"/>
+            <a:off x="4069080" y="2304288"/>
+            <a:ext cx="594360" cy="0"/>
+          </a:xfrm>
+          <a:prstGeom prst="line">
+            <a:avLst/>
+          </a:prstGeom>
+          <a:noFill/>
+          <a:ln w="25400">
+            <a:solidFill>
+              <a:srgbClr val="8A939F"/>
+            </a:solidFill>
+            <a:prstDash val="solid"/>
+            <a:tailEnd type="triangle"/>
+          </a:ln>
+        </p:spPr>
+      </p:sp>
+      <p:sp>
+        <p:nvSpPr>
+          <p:cNvPr id="14" name="Shape 11"/>
+          <p:cNvSpPr/>
+          <p:nvPr/>
+        </p:nvSpPr>
+        <p:spPr>
+          <a:xfrm>
+            <a:off x="4069080" y="3538728"/>
+            <a:ext cx="594360" cy="0"/>
+          </a:xfrm>
+          <a:prstGeom prst="line">
+            <a:avLst/>
+          </a:prstGeom>
+          <a:noFill/>
+          <a:ln w="25400">
+            <a:solidFill>
+              <a:srgbClr val="8A939F"/>
+            </a:solidFill>
+            <a:prstDash val="solid"/>
+            <a:tailEnd type="triangle"/>
+          </a:ln>
+        </p:spPr>
+      </p:sp>
+      <p:sp>
+        <p:nvSpPr>
+          <p:cNvPr id="15" name="Shape 12"/>
+          <p:cNvSpPr/>
+          <p:nvPr/>
+        </p:nvSpPr>
+        <p:spPr>
+          <a:xfrm>
+            <a:off x="4709160" y="1783080"/>
+            <a:ext cx="3566160" cy="2286000"/>
           </a:xfrm>
           <a:prstGeom prst="roundRect">
             <a:avLst>
-              <a:gd name="adj" fmla="val 10000"/>
+              <a:gd name="adj" fmla="val 4000"/>
+            </a:avLst>
+          </a:prstGeom>
+          <a:solidFill>
+            <a:srgbClr val="FFF6F1"/>
+          </a:solidFill>
+          <a:ln w="31750">
+            <a:solidFill>
+              <a:srgbClr val="D9572B"/>
+            </a:solidFill>
+            <a:prstDash val="solid"/>
+          </a:ln>
+        </p:spPr>
+      </p:sp>
+      <p:sp>
+        <p:nvSpPr>
+          <p:cNvPr id="16" name="Text 13"/>
+          <p:cNvSpPr txBox="1"/>
+          <p:nvPr/>
+        </p:nvSpPr>
+        <p:spPr>
+          <a:xfrm>
+            <a:off x="4937760" y="1920240"/>
+            <a:ext cx="3108960" cy="457200"/>
+          </a:xfrm>
+          <a:prstGeom prst="rect">
+            <a:avLst/>
+          </a:prstGeom>
+          <a:noFill/>
+          <a:ln/>
+        </p:spPr>
+        <p:txBody>
+          <a:bodyPr wrap="square" lIns="0" tIns="0" rIns="0" bIns="0" rtlCol="0" anchor="t"/>
+          <a:lstStyle/>
+          <a:p>
+            <a:pPr indent="0" marL="0">
+              <a:buNone/>
+            </a:pPr>
+            <a:r>
+              <a:rPr lang="en-US" sz="2200" b="1" dirty="0">
+                <a:solidFill>
+                  <a:srgbClr val="16202E"/>
+                </a:solidFill>
+                <a:latin typeface="Malgun Gothic" pitchFamily="34" charset="0"/>
+                <a:ea typeface="Malgun Gothic" pitchFamily="34" charset="-122"/>
+                <a:cs typeface="Malgun Gothic" pitchFamily="34" charset="-120"/>
+              </a:rPr>
+              <a:t>STM32</a:t>
+            </a:r>
+            <a:endParaRPr lang="en-US" sz="2200" dirty="0"/>
+          </a:p>
+        </p:txBody>
+      </p:sp>
+      <p:sp>
+        <p:nvSpPr>
+          <p:cNvPr id="17" name="Text 14"/>
+          <p:cNvSpPr txBox="1"/>
+          <p:nvPr/>
+        </p:nvSpPr>
+        <p:spPr>
+          <a:xfrm>
+            <a:off x="4937760" y="2560320"/>
+            <a:ext cx="3200400" cy="1463040"/>
+          </a:xfrm>
+          <a:prstGeom prst="rect">
+            <a:avLst/>
+          </a:prstGeom>
+          <a:noFill/>
+          <a:ln/>
+        </p:spPr>
+        <p:txBody>
+          <a:bodyPr wrap="square" lIns="0" tIns="0" rIns="0" bIns="0" rtlCol="0" anchor="t"/>
+          <a:lstStyle/>
+          <a:p>
+            <a:pPr marL="342900" indent="-342900">
+              <a:spcAft>
+                <a:spcPts val="800"/>
+              </a:spcAft>
+              <a:buSzPct val="100000"/>
+              <a:buChar char="•"/>
+            </a:pPr>
+            <a:r>
+              <a:rPr lang="en-US" sz="1500" dirty="0">
+                <a:solidFill>
+                  <a:srgbClr val="3D4756"/>
+                </a:solidFill>
+                <a:latin typeface="Malgun Gothic" pitchFamily="34" charset="0"/>
+                <a:ea typeface="Malgun Gothic" pitchFamily="34" charset="-122"/>
+                <a:cs typeface="Malgun Gothic" pitchFamily="34" charset="-120"/>
+              </a:rPr>
+              <a:t>모든 센서를 같은 시계로 기록</a:t>
+            </a:r>
+            <a:endParaRPr lang="en-US" sz="1500" dirty="0"/>
+          </a:p>
+          <a:p>
+            <a:pPr marL="342900" indent="-342900">
+              <a:spcAft>
+                <a:spcPts val="800"/>
+              </a:spcAft>
+              <a:buSzPct val="100000"/>
+              <a:buChar char="•"/>
+            </a:pPr>
+            <a:r>
+              <a:rPr lang="en-US" sz="1500" dirty="0">
+                <a:solidFill>
+                  <a:srgbClr val="3D4756"/>
+                </a:solidFill>
+                <a:latin typeface="Malgun Gothic" pitchFamily="34" charset="0"/>
+                <a:ea typeface="Malgun Gothic" pitchFamily="34" charset="-122"/>
+                <a:cs typeface="Malgun Gothic" pitchFamily="34" charset="-120"/>
+              </a:rPr>
+              <a:t>실시간 인과 · 고정지연 필터</a:t>
+            </a:r>
+            <a:endParaRPr lang="en-US" sz="1500" dirty="0"/>
+          </a:p>
+          <a:p>
+            <a:pPr marL="342900" indent="-342900">
+              <a:spcAft>
+                <a:spcPts val="800"/>
+              </a:spcAft>
+              <a:buSzPct val="100000"/>
+              <a:buChar char="•"/>
+            </a:pPr>
+            <a:r>
+              <a:rPr lang="en-US" sz="1500" dirty="0">
+                <a:solidFill>
+                  <a:srgbClr val="3D4756"/>
+                </a:solidFill>
+                <a:latin typeface="Malgun Gothic" pitchFamily="34" charset="0"/>
+                <a:ea typeface="Malgun Gothic" pitchFamily="34" charset="-122"/>
+                <a:cs typeface="Malgun Gothic" pitchFamily="34" charset="-120"/>
+              </a:rPr>
+              <a:t>raw + 필터 출력 동시 저장</a:t>
+            </a:r>
+            <a:endParaRPr lang="en-US" sz="1500" dirty="0"/>
+          </a:p>
+        </p:txBody>
+      </p:sp>
+      <p:sp>
+        <p:nvSpPr>
+          <p:cNvPr id="18" name="Shape 15"/>
+          <p:cNvSpPr/>
+          <p:nvPr/>
+        </p:nvSpPr>
+        <p:spPr>
+          <a:xfrm>
+            <a:off x="8321040" y="2926080"/>
+            <a:ext cx="731520" cy="0"/>
+          </a:xfrm>
+          <a:prstGeom prst="line">
+            <a:avLst/>
+          </a:prstGeom>
+          <a:noFill/>
+          <a:ln w="25400">
+            <a:solidFill>
+              <a:srgbClr val="8A939F"/>
+            </a:solidFill>
+            <a:prstDash val="solid"/>
+            <a:tailEnd type="triangle"/>
+          </a:ln>
+        </p:spPr>
+      </p:sp>
+      <p:sp>
+        <p:nvSpPr>
+          <p:cNvPr id="19" name="Text 16"/>
+          <p:cNvSpPr txBox="1"/>
+          <p:nvPr/>
+        </p:nvSpPr>
+        <p:spPr>
+          <a:xfrm>
+            <a:off x="8321040" y="2606040"/>
+            <a:ext cx="731520" cy="274320"/>
+          </a:xfrm>
+          <a:prstGeom prst="rect">
+            <a:avLst/>
+          </a:prstGeom>
+          <a:noFill/>
+          <a:ln/>
+        </p:spPr>
+        <p:txBody>
+          <a:bodyPr wrap="square" lIns="0" tIns="0" rIns="0" bIns="0" rtlCol="0" anchor="t"/>
+          <a:lstStyle/>
+          <a:p>
+            <a:pPr algn="ctr" indent="0" marL="0">
+              <a:buNone/>
+            </a:pPr>
+            <a:r>
+              <a:rPr lang="en-US" sz="1200" dirty="0">
+                <a:solidFill>
+                  <a:srgbClr val="646D7A"/>
+                </a:solidFill>
+                <a:latin typeface="Courier New" pitchFamily="34" charset="0"/>
+                <a:ea typeface="Courier New" pitchFamily="34" charset="-122"/>
+                <a:cs typeface="Courier New" pitchFamily="34" charset="-120"/>
+              </a:rPr>
+              <a:t>UART</a:t>
+            </a:r>
+            <a:endParaRPr lang="en-US" sz="1200" dirty="0"/>
+          </a:p>
+        </p:txBody>
+      </p:sp>
+      <p:sp>
+        <p:nvSpPr>
+          <p:cNvPr id="20" name="Shape 17"/>
+          <p:cNvSpPr/>
+          <p:nvPr/>
+        </p:nvSpPr>
+        <p:spPr>
+          <a:xfrm>
+            <a:off x="9098280" y="2377440"/>
+            <a:ext cx="2450592" cy="1188720"/>
+          </a:xfrm>
+          <a:prstGeom prst="roundRect">
+            <a:avLst>
+              <a:gd name="adj" fmla="val 7692"/>
             </a:avLst>
           </a:prstGeom>
           <a:solidFill>
@@ -10752,30 +11014,30 @@
       </p:sp>
       <p:sp>
         <p:nvSpPr>
-          <p:cNvPr id="14" name="Text 11"/>
-          <p:cNvSpPr txBox="1"/>
-          <p:nvPr/>
-        </p:nvSpPr>
-        <p:spPr>
-          <a:xfrm>
-            <a:off x="822960" y="3904488"/>
-            <a:ext cx="2926080" cy="365760"/>
-          </a:xfrm>
-          <a:prstGeom prst="rect">
-            <a:avLst/>
-          </a:prstGeom>
-          <a:noFill/>
-          <a:ln/>
-        </p:spPr>
-        <p:txBody>
-          <a:bodyPr wrap="square" lIns="0" tIns="0" rIns="0" bIns="0" rtlCol="0" anchor="t"/>
-          <a:lstStyle/>
-          <a:p>
-            <a:pPr indent="0" marL="0">
-              <a:buNone/>
-            </a:pPr>
-            <a:r>
-              <a:rPr lang="en-US" sz="1600" b="1" dirty="0">
+          <p:cNvPr id="21" name="Text 18"/>
+          <p:cNvSpPr txBox="1"/>
+          <p:nvPr/>
+        </p:nvSpPr>
+        <p:spPr>
+          <a:xfrm>
+            <a:off x="9326880" y="2514600"/>
+            <a:ext cx="1993392" cy="411480"/>
+          </a:xfrm>
+          <a:prstGeom prst="rect">
+            <a:avLst/>
+          </a:prstGeom>
+          <a:noFill/>
+          <a:ln/>
+        </p:spPr>
+        <p:txBody>
+          <a:bodyPr wrap="square" lIns="0" tIns="0" rIns="0" bIns="0" rtlCol="0" anchor="t"/>
+          <a:lstStyle/>
+          <a:p>
+            <a:pPr indent="0" marL="0">
+              <a:buNone/>
+            </a:pPr>
+            <a:r>
+              <a:rPr lang="en-US" sz="1800" b="1" dirty="0">
                 <a:solidFill>
                   <a:srgbClr val="16202E"/>
                 </a:solidFill>
@@ -10783,38 +11045,38 @@
                 <a:ea typeface="Malgun Gothic" pitchFamily="34" charset="-122"/>
                 <a:cs typeface="Malgun Gothic" pitchFamily="34" charset="-120"/>
               </a:rPr>
-              <a:t>자기 엔코더 · AS5600</a:t>
-            </a:r>
-            <a:endParaRPr lang="en-US" sz="1600" dirty="0"/>
-          </a:p>
-        </p:txBody>
-      </p:sp>
-      <p:sp>
-        <p:nvSpPr>
-          <p:cNvPr id="15" name="Text 12"/>
-          <p:cNvSpPr txBox="1"/>
-          <p:nvPr/>
-        </p:nvSpPr>
-        <p:spPr>
-          <a:xfrm>
-            <a:off x="822960" y="4297680"/>
-            <a:ext cx="2926080" cy="365760"/>
-          </a:xfrm>
-          <a:prstGeom prst="rect">
-            <a:avLst/>
-          </a:prstGeom>
-          <a:noFill/>
-          <a:ln/>
-        </p:spPr>
-        <p:txBody>
-          <a:bodyPr wrap="square" lIns="0" tIns="0" rIns="0" bIns="0" rtlCol="0" anchor="t"/>
-          <a:lstStyle/>
-          <a:p>
-            <a:pPr indent="0" marL="0">
-              <a:buNone/>
-            </a:pPr>
-            <a:r>
-              <a:rPr lang="en-US" sz="1300" dirty="0">
+              <a:t>PC</a:t>
+            </a:r>
+            <a:endParaRPr lang="en-US" sz="1800" dirty="0"/>
+          </a:p>
+        </p:txBody>
+      </p:sp>
+      <p:sp>
+        <p:nvSpPr>
+          <p:cNvPr id="22" name="Text 19"/>
+          <p:cNvSpPr txBox="1"/>
+          <p:nvPr/>
+        </p:nvSpPr>
+        <p:spPr>
+          <a:xfrm>
+            <a:off x="9326880" y="2971800"/>
+            <a:ext cx="1993392" cy="548640"/>
+          </a:xfrm>
+          <a:prstGeom prst="rect">
+            <a:avLst/>
+          </a:prstGeom>
+          <a:noFill/>
+          <a:ln/>
+        </p:spPr>
+        <p:txBody>
+          <a:bodyPr wrap="square" lIns="0" tIns="0" rIns="0" bIns="0" rtlCol="0" anchor="t"/>
+          <a:lstStyle/>
+          <a:p>
+            <a:pPr indent="0" marL="0">
+              <a:buNone/>
+            </a:pPr>
+            <a:r>
+              <a:rPr lang="en-US" sz="1400" dirty="0">
                 <a:solidFill>
                   <a:srgbClr val="646D7A"/>
                 </a:solidFill>
@@ -10822,271 +11084,9 @@
                 <a:ea typeface="Malgun Gothic" pitchFamily="34" charset="-122"/>
                 <a:cs typeface="Malgun Gothic" pitchFamily="34" charset="-120"/>
               </a:rPr>
-              <a:t>벤치 회전축 → 각도 참값</a:t>
-            </a:r>
-            <a:endParaRPr lang="en-US" sz="1300" dirty="0"/>
-          </a:p>
-        </p:txBody>
-      </p:sp>
-      <p:sp>
-        <p:nvSpPr>
-          <p:cNvPr id="16" name="Shape 13"/>
-          <p:cNvSpPr/>
-          <p:nvPr/>
-        </p:nvSpPr>
-        <p:spPr>
-          <a:xfrm>
-            <a:off x="3977640" y="2148840"/>
-            <a:ext cx="640080" cy="0"/>
-          </a:xfrm>
-          <a:prstGeom prst="line">
-            <a:avLst/>
-          </a:prstGeom>
-          <a:noFill/>
-          <a:ln w="25400">
-            <a:solidFill>
-              <a:srgbClr val="8A939F"/>
-            </a:solidFill>
-            <a:prstDash val="solid"/>
-            <a:tailEnd type="triangle"/>
-          </a:ln>
-        </p:spPr>
-      </p:sp>
-      <p:sp>
-        <p:nvSpPr>
-          <p:cNvPr id="17" name="Shape 14"/>
-          <p:cNvSpPr/>
-          <p:nvPr/>
-        </p:nvSpPr>
-        <p:spPr>
-          <a:xfrm>
-            <a:off x="3977640" y="3200400"/>
-            <a:ext cx="640080" cy="0"/>
-          </a:xfrm>
-          <a:prstGeom prst="line">
-            <a:avLst/>
-          </a:prstGeom>
-          <a:noFill/>
-          <a:ln w="25400">
-            <a:solidFill>
-              <a:srgbClr val="8A939F"/>
-            </a:solidFill>
-            <a:prstDash val="solid"/>
-            <a:tailEnd type="triangle"/>
-          </a:ln>
-        </p:spPr>
-      </p:sp>
-      <p:sp>
-        <p:nvSpPr>
-          <p:cNvPr id="18" name="Shape 15"/>
-          <p:cNvSpPr/>
-          <p:nvPr/>
-        </p:nvSpPr>
-        <p:spPr>
-          <a:xfrm>
-            <a:off x="3977640" y="4251960"/>
-            <a:ext cx="640080" cy="0"/>
-          </a:xfrm>
-          <a:prstGeom prst="line">
-            <a:avLst/>
-          </a:prstGeom>
-          <a:noFill/>
-          <a:ln w="25400">
-            <a:solidFill>
-              <a:srgbClr val="8A939F"/>
-            </a:solidFill>
-            <a:prstDash val="solid"/>
-            <a:tailEnd type="triangle"/>
-          </a:ln>
-        </p:spPr>
-      </p:sp>
-      <p:sp>
-        <p:nvSpPr>
-          <p:cNvPr id="19" name="Shape 16"/>
-          <p:cNvSpPr/>
-          <p:nvPr/>
-        </p:nvSpPr>
-        <p:spPr>
-          <a:xfrm>
-            <a:off x="4663440" y="1691640"/>
-            <a:ext cx="3657600" cy="3017520"/>
-          </a:xfrm>
-          <a:prstGeom prst="roundRect">
-            <a:avLst>
-              <a:gd name="adj" fmla="val 3030"/>
-            </a:avLst>
-          </a:prstGeom>
-          <a:solidFill>
-            <a:srgbClr val="FFF6F1"/>
-          </a:solidFill>
-          <a:ln w="31750">
-            <a:solidFill>
-              <a:srgbClr val="D9572B"/>
-            </a:solidFill>
-            <a:prstDash val="solid"/>
-          </a:ln>
-        </p:spPr>
-      </p:sp>
-      <p:sp>
-        <p:nvSpPr>
-          <p:cNvPr id="20" name="Text 17"/>
-          <p:cNvSpPr txBox="1"/>
-          <p:nvPr/>
-        </p:nvSpPr>
-        <p:spPr>
-          <a:xfrm>
-            <a:off x="4892040" y="1828800"/>
-            <a:ext cx="3200400" cy="411480"/>
-          </a:xfrm>
-          <a:prstGeom prst="rect">
-            <a:avLst/>
-          </a:prstGeom>
-          <a:noFill/>
-          <a:ln/>
-        </p:spPr>
-        <p:txBody>
-          <a:bodyPr wrap="square" lIns="0" tIns="0" rIns="0" bIns="0" rtlCol="0" anchor="t"/>
-          <a:lstStyle/>
-          <a:p>
-            <a:pPr indent="0" marL="0">
-              <a:buNone/>
-            </a:pPr>
-            <a:r>
-              <a:rPr lang="en-US" sz="1800" b="1" dirty="0">
-                <a:solidFill>
-                  <a:srgbClr val="16202E"/>
-                </a:solidFill>
-                <a:latin typeface="Malgun Gothic" pitchFamily="34" charset="0"/>
-                <a:ea typeface="Malgun Gothic" pitchFamily="34" charset="-122"/>
-                <a:cs typeface="Malgun Gothic" pitchFamily="34" charset="-120"/>
-              </a:rPr>
-              <a:t>STM32 Nucleo-F446RE</a:t>
-            </a:r>
-            <a:endParaRPr lang="en-US" sz="1800" dirty="0"/>
-          </a:p>
-        </p:txBody>
-      </p:sp>
-      <p:sp>
-        <p:nvSpPr>
-          <p:cNvPr id="21" name="Text 18"/>
-          <p:cNvSpPr txBox="1"/>
-          <p:nvPr/>
-        </p:nvSpPr>
-        <p:spPr>
-          <a:xfrm>
-            <a:off x="4892040" y="2286000"/>
-            <a:ext cx="3200400" cy="274320"/>
-          </a:xfrm>
-          <a:prstGeom prst="rect">
-            <a:avLst/>
-          </a:prstGeom>
-          <a:noFill/>
-          <a:ln/>
-        </p:spPr>
-        <p:txBody>
-          <a:bodyPr wrap="square" lIns="0" tIns="0" rIns="0" bIns="0" rtlCol="0" anchor="t"/>
-          <a:lstStyle/>
-          <a:p>
-            <a:pPr indent="0" marL="0">
-              <a:buNone/>
-            </a:pPr>
-            <a:r>
-              <a:rPr lang="en-US" sz="1200" dirty="0">
-                <a:solidFill>
-                  <a:srgbClr val="B4471D"/>
-                </a:solidFill>
-                <a:latin typeface="Courier New" pitchFamily="34" charset="0"/>
-                <a:ea typeface="Courier New" pitchFamily="34" charset="-122"/>
-                <a:cs typeface="Courier New" pitchFamily="34" charset="-120"/>
-              </a:rPr>
-              <a:t>Cortex-M4F 180 MHz · FPU</a:t>
-            </a:r>
-            <a:endParaRPr lang="en-US" sz="1200" dirty="0"/>
-          </a:p>
-        </p:txBody>
-      </p:sp>
-      <p:sp>
-        <p:nvSpPr>
-          <p:cNvPr id="22" name="Text 19"/>
-          <p:cNvSpPr txBox="1"/>
-          <p:nvPr/>
-        </p:nvSpPr>
-        <p:spPr>
-          <a:xfrm>
-            <a:off x="4892040" y="2743200"/>
-            <a:ext cx="3246120" cy="1828800"/>
-          </a:xfrm>
-          <a:prstGeom prst="rect">
-            <a:avLst/>
-          </a:prstGeom>
-          <a:noFill/>
-          <a:ln/>
-        </p:spPr>
-        <p:txBody>
-          <a:bodyPr wrap="square" lIns="0" tIns="0" rIns="0" bIns="0" rtlCol="0" anchor="t"/>
-          <a:lstStyle/>
-          <a:p>
-            <a:pPr marL="342900" indent="-342900">
-              <a:spcAft>
-                <a:spcPts val="800"/>
-              </a:spcAft>
-              <a:buSzPct val="100000"/>
-              <a:buChar char="•"/>
-            </a:pPr>
-            <a:r>
-              <a:rPr lang="en-US" sz="1500" dirty="0">
-                <a:solidFill>
-                  <a:srgbClr val="3D4756"/>
-                </a:solidFill>
-                <a:latin typeface="Malgun Gothic" pitchFamily="34" charset="0"/>
-                <a:ea typeface="Malgun Gothic" pitchFamily="34" charset="-122"/>
-                <a:cs typeface="Malgun Gothic" pitchFamily="34" charset="-120"/>
-              </a:rPr>
-              <a:t>1 µs 타이머 공통 타임스탬프</a:t>
-            </a:r>
-            <a:endParaRPr lang="en-US" sz="1500" dirty="0"/>
-          </a:p>
-          <a:p>
-            <a:pPr marL="342900" indent="-342900">
-              <a:spcAft>
-                <a:spcPts val="800"/>
-              </a:spcAft>
-              <a:buSzPct val="100000"/>
-              <a:buChar char="•"/>
-            </a:pPr>
-            <a:r>
-              <a:rPr lang="en-US" sz="1500" dirty="0">
-                <a:solidFill>
-                  <a:srgbClr val="3D4756"/>
-                </a:solidFill>
-                <a:latin typeface="Malgun Gothic" pitchFamily="34" charset="0"/>
-                <a:ea typeface="Malgun Gothic" pitchFamily="34" charset="-122"/>
-                <a:cs typeface="Malgun Gothic" pitchFamily="34" charset="-120"/>
-              </a:rPr>
-              <a:t>실시간 인과 · 고정지연 필터</a:t>
-            </a:r>
-            <a:endParaRPr lang="en-US" sz="1500" dirty="0"/>
-          </a:p>
-          <a:p>
-            <a:pPr marL="342900" indent="-342900">
-              <a:spcAft>
-                <a:spcPts val="800"/>
-              </a:spcAft>
-              <a:buSzPct val="100000"/>
-              <a:buChar char="•"/>
-            </a:pPr>
-            <a:r>
-              <a:rPr lang="en-US" sz="1500" dirty="0">
-                <a:solidFill>
-                  <a:srgbClr val="3D4756"/>
-                </a:solidFill>
-                <a:latin typeface="Malgun Gothic" pitchFamily="34" charset="0"/>
-                <a:ea typeface="Malgun Gothic" pitchFamily="34" charset="-122"/>
-                <a:cs typeface="Malgun Gothic" pitchFamily="34" charset="-120"/>
-              </a:rPr>
-              <a:t>raw + 필터 출력 동시 로깅</a:t>
-            </a:r>
-            <a:endParaRPr lang="en-US" sz="1500" dirty="0"/>
+              <a:t>비인과 필터 · 분석</a:t>
+            </a:r>
+            <a:endParaRPr lang="en-US" sz="1400" dirty="0"/>
           </a:p>
         </p:txBody>
       </p:sp>
@@ -11098,71 +11098,8 @@
         </p:nvSpPr>
         <p:spPr>
           <a:xfrm>
-            <a:off x="8366760" y="3200400"/>
-            <a:ext cx="731520" cy="0"/>
-          </a:xfrm>
-          <a:prstGeom prst="line">
-            <a:avLst/>
-          </a:prstGeom>
-          <a:noFill/>
-          <a:ln w="25400">
-            <a:solidFill>
-              <a:srgbClr val="8A939F"/>
-            </a:solidFill>
-            <a:prstDash val="solid"/>
-            <a:tailEnd type="triangle"/>
-          </a:ln>
-        </p:spPr>
-      </p:sp>
-      <p:sp>
-        <p:nvSpPr>
-          <p:cNvPr id="24" name="Text 21"/>
-          <p:cNvSpPr txBox="1"/>
-          <p:nvPr/>
-        </p:nvSpPr>
-        <p:spPr>
-          <a:xfrm>
-            <a:off x="8366760" y="2880360"/>
-            <a:ext cx="731520" cy="274320"/>
-          </a:xfrm>
-          <a:prstGeom prst="rect">
-            <a:avLst/>
-          </a:prstGeom>
-          <a:noFill/>
-          <a:ln/>
-        </p:spPr>
-        <p:txBody>
-          <a:bodyPr wrap="square" lIns="0" tIns="0" rIns="0" bIns="0" rtlCol="0" anchor="t"/>
-          <a:lstStyle/>
-          <a:p>
-            <a:pPr algn="ctr" indent="0" marL="0">
-              <a:buNone/>
-            </a:pPr>
-            <a:r>
-              <a:rPr lang="en-US" sz="1200" dirty="0">
-                <a:solidFill>
-                  <a:srgbClr val="646D7A"/>
-                </a:solidFill>
-                <a:latin typeface="Courier New" pitchFamily="34" charset="0"/>
-                <a:ea typeface="Courier New" pitchFamily="34" charset="-122"/>
-                <a:cs typeface="Courier New" pitchFamily="34" charset="-120"/>
-              </a:rPr>
-              <a:t>UART</a:t>
-            </a:r>
-            <a:endParaRPr lang="en-US" sz="1200" dirty="0"/>
-          </a:p>
-        </p:txBody>
-      </p:sp>
-      <p:sp>
-        <p:nvSpPr>
-          <p:cNvPr id="25" name="Shape 22"/>
-          <p:cNvSpPr/>
-          <p:nvPr/>
-        </p:nvSpPr>
-        <p:spPr>
-          <a:xfrm>
-            <a:off x="9144000" y="2606040"/>
-            <a:ext cx="2404872" cy="1188720"/>
+            <a:off x="640080" y="4434840"/>
+            <a:ext cx="4023360" cy="1188720"/>
           </a:xfrm>
           <a:prstGeom prst="roundRect">
             <a:avLst>
@@ -11182,30 +11119,30 @@
       </p:sp>
       <p:sp>
         <p:nvSpPr>
-          <p:cNvPr id="26" name="Text 23"/>
-          <p:cNvSpPr txBox="1"/>
-          <p:nvPr/>
-        </p:nvSpPr>
-        <p:spPr>
-          <a:xfrm>
-            <a:off x="9326880" y="2715768"/>
-            <a:ext cx="2039112" cy="365760"/>
-          </a:xfrm>
-          <a:prstGeom prst="rect">
-            <a:avLst/>
-          </a:prstGeom>
-          <a:noFill/>
-          <a:ln/>
-        </p:spPr>
-        <p:txBody>
-          <a:bodyPr wrap="square" lIns="0" tIns="0" rIns="0" bIns="0" rtlCol="0" anchor="t"/>
-          <a:lstStyle/>
-          <a:p>
-            <a:pPr indent="0" marL="0">
-              <a:buNone/>
-            </a:pPr>
-            <a:r>
-              <a:rPr lang="en-US" sz="1600" b="1" dirty="0">
+          <p:cNvPr id="24" name="Text 21"/>
+          <p:cNvSpPr txBox="1"/>
+          <p:nvPr/>
+        </p:nvSpPr>
+        <p:spPr>
+          <a:xfrm>
+            <a:off x="868680" y="4572000"/>
+            <a:ext cx="3566160" cy="411480"/>
+          </a:xfrm>
+          <a:prstGeom prst="rect">
+            <a:avLst/>
+          </a:prstGeom>
+          <a:noFill/>
+          <a:ln/>
+        </p:spPr>
+        <p:txBody>
+          <a:bodyPr wrap="square" lIns="0" tIns="0" rIns="0" bIns="0" rtlCol="0" anchor="t"/>
+          <a:lstStyle/>
+          <a:p>
+            <a:pPr indent="0" marL="0">
+              <a:buNone/>
+            </a:pPr>
+            <a:r>
+              <a:rPr lang="en-US" sz="1800" b="1" dirty="0">
                 <a:solidFill>
                   <a:srgbClr val="16202E"/>
                 </a:solidFill>
@@ -11213,11 +11150,74 @@
                 <a:ea typeface="Malgun Gothic" pitchFamily="34" charset="-122"/>
                 <a:cs typeface="Malgun Gothic" pitchFamily="34" charset="-120"/>
               </a:rPr>
-              <a:t>PC</a:t>
-            </a:r>
-            <a:endParaRPr lang="en-US" sz="1600" dirty="0"/>
-          </a:p>
-        </p:txBody>
+              <a:t>Arduino</a:t>
+            </a:r>
+            <a:endParaRPr lang="en-US" sz="1800" dirty="0"/>
+          </a:p>
+        </p:txBody>
+      </p:sp>
+      <p:sp>
+        <p:nvSpPr>
+          <p:cNvPr id="25" name="Text 22"/>
+          <p:cNvSpPr txBox="1"/>
+          <p:nvPr/>
+        </p:nvSpPr>
+        <p:spPr>
+          <a:xfrm>
+            <a:off x="868680" y="5029200"/>
+            <a:ext cx="3566160" cy="548640"/>
+          </a:xfrm>
+          <a:prstGeom prst="rect">
+            <a:avLst/>
+          </a:prstGeom>
+          <a:noFill/>
+          <a:ln/>
+        </p:spPr>
+        <p:txBody>
+          <a:bodyPr wrap="square" lIns="0" tIns="0" rIns="0" bIns="0" rtlCol="0" anchor="t"/>
+          <a:lstStyle/>
+          <a:p>
+            <a:pPr indent="0" marL="0">
+              <a:buNone/>
+            </a:pPr>
+            <a:r>
+              <a:rPr lang="en-US" sz="1400" dirty="0">
+                <a:solidFill>
+                  <a:srgbClr val="646D7A"/>
+                </a:solidFill>
+                <a:latin typeface="Malgun Gothic" pitchFamily="34" charset="0"/>
+                <a:ea typeface="Malgun Gothic" pitchFamily="34" charset="-122"/>
+                <a:cs typeface="Malgun Gothic" pitchFamily="34" charset="-120"/>
+              </a:rPr>
+              <a:t>서보 모터 구동 · 저사양 MCU 비교</a:t>
+            </a:r>
+            <a:endParaRPr lang="en-US" sz="1400" dirty="0"/>
+          </a:p>
+        </p:txBody>
+      </p:sp>
+      <p:sp>
+        <p:nvSpPr>
+          <p:cNvPr id="26" name="Shape 23"/>
+          <p:cNvSpPr/>
+          <p:nvPr/>
+        </p:nvSpPr>
+        <p:spPr>
+          <a:xfrm>
+            <a:off x="4709160" y="5029200"/>
+            <a:ext cx="914400" cy="0"/>
+          </a:xfrm>
+          <a:prstGeom prst="line">
+            <a:avLst/>
+          </a:prstGeom>
+          <a:noFill/>
+          <a:ln w="25400">
+            <a:solidFill>
+              <a:srgbClr val="8A939F"/>
+            </a:solidFill>
+            <a:prstDash val="solid"/>
+            <a:tailEnd type="triangle"/>
+          </a:ln>
+        </p:spPr>
       </p:sp>
       <p:sp>
         <p:nvSpPr>
@@ -11227,34 +11227,34 @@
         </p:nvSpPr>
         <p:spPr>
           <a:xfrm>
-            <a:off x="9326880" y="3108960"/>
-            <a:ext cx="2039112" cy="640080"/>
-          </a:xfrm>
-          <a:prstGeom prst="rect">
-            <a:avLst/>
-          </a:prstGeom>
-          <a:noFill/>
-          <a:ln/>
-        </p:spPr>
-        <p:txBody>
-          <a:bodyPr wrap="square" lIns="0" tIns="0" rIns="0" bIns="0" rtlCol="0" anchor="t"/>
-          <a:lstStyle/>
-          <a:p>
-            <a:pPr indent="0" marL="0">
-              <a:buNone/>
-            </a:pPr>
-            <a:r>
-              <a:rPr lang="en-US" sz="1300" dirty="0">
+            <a:off x="4709160" y="4709160"/>
+            <a:ext cx="914400" cy="274320"/>
+          </a:xfrm>
+          <a:prstGeom prst="rect">
+            <a:avLst/>
+          </a:prstGeom>
+          <a:noFill/>
+          <a:ln/>
+        </p:spPr>
+        <p:txBody>
+          <a:bodyPr wrap="square" lIns="0" tIns="0" rIns="0" bIns="0" rtlCol="0" anchor="t"/>
+          <a:lstStyle/>
+          <a:p>
+            <a:pPr algn="ctr" indent="0" marL="0">
+              <a:buNone/>
+            </a:pPr>
+            <a:r>
+              <a:rPr lang="en-US" sz="1200" dirty="0">
                 <a:solidFill>
                   <a:srgbClr val="646D7A"/>
                 </a:solidFill>
-                <a:latin typeface="Malgun Gothic" pitchFamily="34" charset="0"/>
-                <a:ea typeface="Malgun Gothic" pitchFamily="34" charset="-122"/>
-                <a:cs typeface="Malgun Gothic" pitchFamily="34" charset="-120"/>
-              </a:rPr>
-              <a:t>비인과 필터 · 지표 · 통계</a:t>
-            </a:r>
-            <a:endParaRPr lang="en-US" sz="1300" dirty="0"/>
+                <a:latin typeface="Courier New" pitchFamily="34" charset="0"/>
+                <a:ea typeface="Courier New" pitchFamily="34" charset="-122"/>
+                <a:cs typeface="Courier New" pitchFamily="34" charset="-120"/>
+              </a:rPr>
+              <a:t>PWM</a:t>
+            </a:r>
+            <a:endParaRPr lang="en-US" sz="1200" dirty="0"/>
           </a:p>
         </p:txBody>
       </p:sp>
@@ -11266,12 +11266,12 @@
         </p:nvSpPr>
         <p:spPr>
           <a:xfrm>
-            <a:off x="640080" y="5029200"/>
-            <a:ext cx="4023360" cy="1051560"/>
+            <a:off x="5669280" y="4434840"/>
+            <a:ext cx="2926080" cy="1188720"/>
           </a:xfrm>
           <a:prstGeom prst="roundRect">
             <a:avLst>
-              <a:gd name="adj" fmla="val 8696"/>
+              <a:gd name="adj" fmla="val 7692"/>
             </a:avLst>
           </a:prstGeom>
           <a:solidFill>
@@ -11293,24 +11293,24 @@
         </p:nvSpPr>
         <p:spPr>
           <a:xfrm>
-            <a:off x="822960" y="5138928"/>
-            <a:ext cx="3657600" cy="365760"/>
-          </a:xfrm>
-          <a:prstGeom prst="rect">
-            <a:avLst/>
-          </a:prstGeom>
-          <a:noFill/>
-          <a:ln/>
-        </p:spPr>
-        <p:txBody>
-          <a:bodyPr wrap="square" lIns="0" tIns="0" rIns="0" bIns="0" rtlCol="0" anchor="t"/>
-          <a:lstStyle/>
-          <a:p>
-            <a:pPr indent="0" marL="0">
-              <a:buNone/>
-            </a:pPr>
-            <a:r>
-              <a:rPr lang="en-US" sz="1600" b="1" dirty="0">
+            <a:off x="5897880" y="4572000"/>
+            <a:ext cx="2468880" cy="411480"/>
+          </a:xfrm>
+          <a:prstGeom prst="rect">
+            <a:avLst/>
+          </a:prstGeom>
+          <a:noFill/>
+          <a:ln/>
+        </p:spPr>
+        <p:txBody>
+          <a:bodyPr wrap="square" lIns="0" tIns="0" rIns="0" bIns="0" rtlCol="0" anchor="t"/>
+          <a:lstStyle/>
+          <a:p>
+            <a:pPr indent="0" marL="0">
+              <a:buNone/>
+            </a:pPr>
+            <a:r>
+              <a:rPr lang="en-US" sz="1800" b="1" dirty="0">
                 <a:solidFill>
                   <a:srgbClr val="16202E"/>
                 </a:solidFill>
@@ -11318,9 +11318,9 @@
                 <a:ea typeface="Malgun Gothic" pitchFamily="34" charset="-122"/>
                 <a:cs typeface="Malgun Gothic" pitchFamily="34" charset="-120"/>
               </a:rPr>
-              <a:t>Arduino Uno</a:t>
-            </a:r>
-            <a:endParaRPr lang="en-US" sz="1600" dirty="0"/>
+              <a:t>서보 모터</a:t>
+            </a:r>
+            <a:endParaRPr lang="en-US" sz="1800" dirty="0"/>
           </a:p>
         </p:txBody>
       </p:sp>
@@ -11332,24 +11332,24 @@
         </p:nvSpPr>
         <p:spPr>
           <a:xfrm>
-            <a:off x="822960" y="5532120"/>
-            <a:ext cx="3657600" cy="502920"/>
-          </a:xfrm>
-          <a:prstGeom prst="rect">
-            <a:avLst/>
-          </a:prstGeom>
-          <a:noFill/>
-          <a:ln/>
-        </p:spPr>
-        <p:txBody>
-          <a:bodyPr wrap="square" lIns="0" tIns="0" rIns="0" bIns="0" rtlCol="0" anchor="t"/>
-          <a:lstStyle/>
-          <a:p>
-            <a:pPr indent="0" marL="0">
-              <a:buNone/>
-            </a:pPr>
-            <a:r>
-              <a:rPr lang="en-US" sz="1300" dirty="0">
+            <a:off x="5897880" y="5029200"/>
+            <a:ext cx="2468880" cy="548640"/>
+          </a:xfrm>
+          <a:prstGeom prst="rect">
+            <a:avLst/>
+          </a:prstGeom>
+          <a:noFill/>
+          <a:ln/>
+        </p:spPr>
+        <p:txBody>
+          <a:bodyPr wrap="square" lIns="0" tIns="0" rIns="0" bIns="0" rtlCol="0" anchor="t"/>
+          <a:lstStyle/>
+          <a:p>
+            <a:pPr indent="0" marL="0">
+              <a:buNone/>
+            </a:pPr>
+            <a:r>
+              <a:rPr lang="en-US" sz="1400" dirty="0">
                 <a:solidFill>
                   <a:srgbClr val="646D7A"/>
                 </a:solidFill>
@@ -11357,213 +11357,22 @@
                 <a:ea typeface="Malgun Gothic" pitchFamily="34" charset="-122"/>
                 <a:cs typeface="Malgun Gothic" pitchFamily="34" charset="-120"/>
               </a:rPr>
-              <a:t>서보 구동 · 저사양 MCU 연산 비교</a:t>
-            </a:r>
-            <a:endParaRPr lang="en-US" sz="1300" dirty="0"/>
-          </a:p>
-        </p:txBody>
-      </p:sp>
-      <p:sp>
-        <p:nvSpPr>
-          <p:cNvPr id="31" name="Shape 28"/>
-          <p:cNvSpPr/>
-          <p:nvPr/>
-        </p:nvSpPr>
-        <p:spPr>
-          <a:xfrm>
-            <a:off x="4709160" y="5550408"/>
-            <a:ext cx="822960" cy="0"/>
-          </a:xfrm>
-          <a:prstGeom prst="line">
-            <a:avLst/>
-          </a:prstGeom>
-          <a:noFill/>
-          <a:ln w="25400">
-            <a:solidFill>
-              <a:srgbClr val="8A939F"/>
-            </a:solidFill>
-            <a:prstDash val="solid"/>
-            <a:tailEnd type="triangle"/>
-          </a:ln>
-        </p:spPr>
-      </p:sp>
-      <p:sp>
-        <p:nvSpPr>
-          <p:cNvPr id="32" name="Text 29"/>
-          <p:cNvSpPr txBox="1"/>
-          <p:nvPr/>
-        </p:nvSpPr>
-        <p:spPr>
-          <a:xfrm>
-            <a:off x="4709160" y="5230368"/>
-            <a:ext cx="822960" cy="274320"/>
-          </a:xfrm>
-          <a:prstGeom prst="rect">
-            <a:avLst/>
-          </a:prstGeom>
-          <a:noFill/>
-          <a:ln/>
-        </p:spPr>
-        <p:txBody>
-          <a:bodyPr wrap="square" lIns="0" tIns="0" rIns="0" bIns="0" rtlCol="0" anchor="t"/>
-          <a:lstStyle/>
-          <a:p>
-            <a:pPr algn="ctr" indent="0" marL="0">
-              <a:buNone/>
-            </a:pPr>
-            <a:r>
-              <a:rPr lang="en-US" sz="1200" dirty="0">
-                <a:solidFill>
-                  <a:srgbClr val="646D7A"/>
-                </a:solidFill>
-                <a:latin typeface="Courier New" pitchFamily="34" charset="0"/>
-                <a:ea typeface="Courier New" pitchFamily="34" charset="-122"/>
-                <a:cs typeface="Courier New" pitchFamily="34" charset="-120"/>
-              </a:rPr>
-              <a:t>PWM</a:t>
-            </a:r>
-            <a:endParaRPr lang="en-US" sz="1200" dirty="0"/>
-          </a:p>
-        </p:txBody>
-      </p:sp>
-      <p:sp>
-        <p:nvSpPr>
-          <p:cNvPr id="33" name="Shape 30"/>
-          <p:cNvSpPr/>
-          <p:nvPr/>
-        </p:nvSpPr>
-        <p:spPr>
-          <a:xfrm>
-            <a:off x="5577840" y="5029200"/>
-            <a:ext cx="2743200" cy="1051560"/>
-          </a:xfrm>
-          <a:prstGeom prst="roundRect">
-            <a:avLst>
-              <a:gd name="adj" fmla="val 8696"/>
-            </a:avLst>
-          </a:prstGeom>
-          <a:solidFill>
-            <a:srgbClr val="FDFCFA"/>
-          </a:solidFill>
-          <a:ln w="12700">
-            <a:solidFill>
-              <a:srgbClr val="CDD3DA"/>
-            </a:solidFill>
-            <a:prstDash val="solid"/>
-          </a:ln>
-        </p:spPr>
-      </p:sp>
-      <p:sp>
-        <p:nvSpPr>
-          <p:cNvPr id="34" name="Text 31"/>
-          <p:cNvSpPr txBox="1"/>
-          <p:nvPr/>
-        </p:nvSpPr>
-        <p:spPr>
-          <a:xfrm>
-            <a:off x="5760720" y="5138928"/>
-            <a:ext cx="2377440" cy="365760"/>
-          </a:xfrm>
-          <a:prstGeom prst="rect">
-            <a:avLst/>
-          </a:prstGeom>
-          <a:noFill/>
-          <a:ln/>
-        </p:spPr>
-        <p:txBody>
-          <a:bodyPr wrap="square" lIns="0" tIns="0" rIns="0" bIns="0" rtlCol="0" anchor="t"/>
-          <a:lstStyle/>
-          <a:p>
-            <a:pPr indent="0" marL="0">
-              <a:buNone/>
-            </a:pPr>
-            <a:r>
-              <a:rPr lang="en-US" sz="1600" b="1" dirty="0">
-                <a:solidFill>
-                  <a:srgbClr val="16202E"/>
-                </a:solidFill>
-                <a:latin typeface="Malgun Gothic" pitchFamily="34" charset="0"/>
-                <a:ea typeface="Malgun Gothic" pitchFamily="34" charset="-122"/>
-                <a:cs typeface="Malgun Gothic" pitchFamily="34" charset="-120"/>
-              </a:rPr>
-              <a:t>MG996R 서보</a:t>
-            </a:r>
-            <a:endParaRPr lang="en-US" sz="1600" dirty="0"/>
-          </a:p>
-        </p:txBody>
-      </p:sp>
-      <p:sp>
-        <p:nvSpPr>
-          <p:cNvPr id="35" name="Text 32"/>
-          <p:cNvSpPr txBox="1"/>
-          <p:nvPr/>
-        </p:nvSpPr>
-        <p:spPr>
-          <a:xfrm>
-            <a:off x="5760720" y="5532120"/>
-            <a:ext cx="2377440" cy="502920"/>
-          </a:xfrm>
-          <a:prstGeom prst="rect">
-            <a:avLst/>
-          </a:prstGeom>
-          <a:noFill/>
-          <a:ln/>
-        </p:spPr>
-        <p:txBody>
-          <a:bodyPr wrap="square" lIns="0" tIns="0" rIns="0" bIns="0" rtlCol="0" anchor="t"/>
-          <a:lstStyle/>
-          <a:p>
-            <a:pPr indent="0" marL="0">
-              <a:buNone/>
-            </a:pPr>
-            <a:r>
-              <a:rPr lang="en-US" sz="1300" dirty="0">
-                <a:solidFill>
-                  <a:srgbClr val="646D7A"/>
-                </a:solidFill>
-                <a:latin typeface="Malgun Gothic" pitchFamily="34" charset="0"/>
-                <a:ea typeface="Malgun Gothic" pitchFamily="34" charset="-122"/>
-                <a:cs typeface="Malgun Gothic" pitchFamily="34" charset="-120"/>
-              </a:rPr>
               <a:t>벤치 링크 구동</a:t>
             </a:r>
-            <a:endParaRPr lang="en-US" sz="1300" dirty="0"/>
-          </a:p>
-        </p:txBody>
-      </p:sp>
-      <p:sp>
-        <p:nvSpPr>
-          <p:cNvPr id="36" name="Shape 33"/>
-          <p:cNvSpPr/>
-          <p:nvPr/>
-        </p:nvSpPr>
-        <p:spPr>
-          <a:xfrm>
-            <a:off x="2743200" y="5029200"/>
-            <a:ext cx="1920240" cy="-320040"/>
-          </a:xfrm>
-          <a:prstGeom prst="line">
-            <a:avLst/>
-          </a:prstGeom>
-          <a:noFill/>
-          <a:ln w="19050">
-            <a:solidFill>
-              <a:srgbClr val="8A939F"/>
-            </a:solidFill>
-            <a:prstDash val="dash"/>
-          </a:ln>
-        </p:spPr>
-      </p:sp>
-      <p:sp>
-        <p:nvSpPr>
-          <p:cNvPr id="37" name="Text 34"/>
-          <p:cNvSpPr txBox="1"/>
-          <p:nvPr/>
-        </p:nvSpPr>
-        <p:spPr>
-          <a:xfrm>
-            <a:off x="8503920" y="5120640"/>
-            <a:ext cx="3017520" cy="914400"/>
+            <a:endParaRPr lang="en-US" sz="1400" dirty="0"/>
+          </a:p>
+        </p:txBody>
+      </p:sp>
+      <p:sp>
+        <p:nvSpPr>
+          <p:cNvPr id="31" name="Text 28"/>
+          <p:cNvSpPr txBox="1"/>
+          <p:nvPr/>
+        </p:nvSpPr>
+        <p:spPr>
+          <a:xfrm>
+            <a:off x="8961120" y="4480560"/>
+            <a:ext cx="2606040" cy="1097280"/>
           </a:xfrm>
           <a:prstGeom prst="rect">
             <a:avLst/>

</xml_diff>